<commit_message>
update evaluate and slide
</commit_message>
<xml_diff>
--- a/docs/food_moo_duu_slides.pptx
+++ b/docs/food_moo_duu_slides.pptx
@@ -25,6 +25,10 @@
     <p:sldId id="273" r:id="rId19"/>
     <p:sldId id="274" r:id="rId20"/>
     <p:sldId id="275" r:id="rId21"/>
+    <p:sldId id="276" r:id="rId22"/>
+    <p:sldId id="277" r:id="rId23"/>
+    <p:sldId id="278" r:id="rId24"/>
+    <p:sldId id="279" r:id="rId25"/>
   </p:sldIdLst>
   <p:sldSz cx="12192000" cy="6858000"/>
   <p:notesSz cx="6858000" cy="9144000"/>
@@ -323,7 +327,7 @@
           <a:p>
             <a:fld id="{5BCAD085-E8A6-8845-BD4E-CB4CCA059FC4}" type="datetimeFigureOut">
               <a:rPr lang="en-US" smtClean="0"/>
-              <a:t>6/9/2026</a:t>
+              <a:t>6/10/2026</a:t>
             </a:fld>
             <a:endParaRPr lang="en-US"/>
           </a:p>
@@ -493,7 +497,7 @@
           <a:p>
             <a:fld id="{5BCAD085-E8A6-8845-BD4E-CB4CCA059FC4}" type="datetimeFigureOut">
               <a:rPr lang="en-US" smtClean="0"/>
-              <a:t>6/9/2026</a:t>
+              <a:t>6/10/2026</a:t>
             </a:fld>
             <a:endParaRPr lang="en-US"/>
           </a:p>
@@ -673,7 +677,7 @@
           <a:p>
             <a:fld id="{5BCAD085-E8A6-8845-BD4E-CB4CCA059FC4}" type="datetimeFigureOut">
               <a:rPr lang="en-US" smtClean="0"/>
-              <a:t>6/9/2026</a:t>
+              <a:t>6/10/2026</a:t>
             </a:fld>
             <a:endParaRPr lang="en-US"/>
           </a:p>
@@ -843,7 +847,7 @@
           <a:p>
             <a:fld id="{5BCAD085-E8A6-8845-BD4E-CB4CCA059FC4}" type="datetimeFigureOut">
               <a:rPr lang="en-US" smtClean="0"/>
-              <a:t>6/9/2026</a:t>
+              <a:t>6/10/2026</a:t>
             </a:fld>
             <a:endParaRPr lang="en-US"/>
           </a:p>
@@ -1089,7 +1093,7 @@
           <a:p>
             <a:fld id="{5BCAD085-E8A6-8845-BD4E-CB4CCA059FC4}" type="datetimeFigureOut">
               <a:rPr lang="en-US" smtClean="0"/>
-              <a:t>6/9/2026</a:t>
+              <a:t>6/10/2026</a:t>
             </a:fld>
             <a:endParaRPr lang="en-US"/>
           </a:p>
@@ -1377,7 +1381,7 @@
           <a:p>
             <a:fld id="{5BCAD085-E8A6-8845-BD4E-CB4CCA059FC4}" type="datetimeFigureOut">
               <a:rPr lang="en-US" smtClean="0"/>
-              <a:t>6/9/2026</a:t>
+              <a:t>6/10/2026</a:t>
             </a:fld>
             <a:endParaRPr lang="en-US"/>
           </a:p>
@@ -1799,7 +1803,7 @@
           <a:p>
             <a:fld id="{5BCAD085-E8A6-8845-BD4E-CB4CCA059FC4}" type="datetimeFigureOut">
               <a:rPr lang="en-US" smtClean="0"/>
-              <a:t>6/9/2026</a:t>
+              <a:t>6/10/2026</a:t>
             </a:fld>
             <a:endParaRPr lang="en-US"/>
           </a:p>
@@ -1917,7 +1921,7 @@
           <a:p>
             <a:fld id="{5BCAD085-E8A6-8845-BD4E-CB4CCA059FC4}" type="datetimeFigureOut">
               <a:rPr lang="en-US" smtClean="0"/>
-              <a:t>6/9/2026</a:t>
+              <a:t>6/10/2026</a:t>
             </a:fld>
             <a:endParaRPr lang="en-US"/>
           </a:p>
@@ -2012,7 +2016,7 @@
           <a:p>
             <a:fld id="{5BCAD085-E8A6-8845-BD4E-CB4CCA059FC4}" type="datetimeFigureOut">
               <a:rPr lang="en-US" smtClean="0"/>
-              <a:t>6/9/2026</a:t>
+              <a:t>6/10/2026</a:t>
             </a:fld>
             <a:endParaRPr lang="en-US"/>
           </a:p>
@@ -2289,7 +2293,7 @@
           <a:p>
             <a:fld id="{5BCAD085-E8A6-8845-BD4E-CB4CCA059FC4}" type="datetimeFigureOut">
               <a:rPr lang="en-US" smtClean="0"/>
-              <a:t>6/9/2026</a:t>
+              <a:t>6/10/2026</a:t>
             </a:fld>
             <a:endParaRPr lang="en-US"/>
           </a:p>
@@ -2542,7 +2546,7 @@
           <a:p>
             <a:fld id="{5BCAD085-E8A6-8845-BD4E-CB4CCA059FC4}" type="datetimeFigureOut">
               <a:rPr lang="en-US" smtClean="0"/>
-              <a:t>6/9/2026</a:t>
+              <a:t>6/10/2026</a:t>
             </a:fld>
             <a:endParaRPr lang="en-US"/>
           </a:p>
@@ -2755,7 +2759,7 @@
           <a:p>
             <a:fld id="{5BCAD085-E8A6-8845-BD4E-CB4CCA059FC4}" type="datetimeFigureOut">
               <a:rPr lang="en-US" smtClean="0"/>
-              <a:t>6/9/2026</a:t>
+              <a:t>6/10/2026</a:t>
             </a:fld>
             <a:endParaRPr lang="en-US"/>
           </a:p>
@@ -3191,7 +3195,7 @@
         <p:spPr>
           <a:xfrm>
             <a:off x="900000" y="1700000"/>
-            <a:ext cx="10400000" cy="1882567"/>
+            <a:ext cx="10400000" cy="1800000"/>
           </a:xfrm>
           <a:prstGeom prst="rect">
             <a:avLst/>
@@ -3205,154 +3209,14 @@
           <a:lstStyle/>
           <a:p>
             <a:r>
-              <a:rPr sz="4400" b="1" i="0" dirty="0">
+              <a:rPr sz="4400" b="1" i="0">
                 <a:solidFill>
                   <a:srgbClr val="FFFFFF"/>
                 </a:solidFill>
                 <a:latin typeface="Calibri"/>
               </a:rPr>
-              <a:t>Food Moo </a:t>
-            </a:r>
-            <a:r>
-              <a:rPr sz="4400" b="1" i="0" dirty="0" err="1" smtClean="0">
-                <a:solidFill>
-                  <a:srgbClr val="FFFFFF"/>
-                </a:solidFill>
-                <a:latin typeface="Calibri"/>
-              </a:rPr>
-              <a:t>Duu</a:t>
-            </a:r>
-            <a:endParaRPr lang="en-US" sz="4400" b="1" i="0" dirty="0" smtClean="0">
-              <a:solidFill>
-                <a:srgbClr val="FFFFFF"/>
-              </a:solidFill>
-              <a:latin typeface="Calibri"/>
-            </a:endParaRPr>
-          </a:p>
-          <a:p>
-            <a:r>
-              <a:rPr sz="4400" b="1" i="0" dirty="0" err="1" smtClean="0">
-                <a:solidFill>
-                  <a:srgbClr val="FFFFFF"/>
-                </a:solidFill>
-                <a:latin typeface="Calibri"/>
-              </a:rPr>
-              <a:t>Hệ</a:t>
-            </a:r>
-            <a:r>
-              <a:rPr sz="4400" b="1" i="0" dirty="0" smtClean="0">
-                <a:solidFill>
-                  <a:srgbClr val="FFFFFF"/>
-                </a:solidFill>
-                <a:latin typeface="Calibri"/>
-              </a:rPr>
-              <a:t> </a:t>
-            </a:r>
-            <a:r>
-              <a:rPr sz="4400" b="1" i="0" dirty="0" err="1">
-                <a:solidFill>
-                  <a:srgbClr val="FFFFFF"/>
-                </a:solidFill>
-                <a:latin typeface="Calibri"/>
-              </a:rPr>
-              <a:t>thống</a:t>
-            </a:r>
-            <a:r>
-              <a:rPr sz="4400" b="1" i="0" dirty="0">
-                <a:solidFill>
-                  <a:srgbClr val="FFFFFF"/>
-                </a:solidFill>
-                <a:latin typeface="Calibri"/>
-              </a:rPr>
-              <a:t> </a:t>
-            </a:r>
-            <a:r>
-              <a:rPr sz="4400" b="1" i="0" dirty="0" err="1">
-                <a:solidFill>
-                  <a:srgbClr val="FFFFFF"/>
-                </a:solidFill>
-                <a:latin typeface="Calibri"/>
-              </a:rPr>
-              <a:t>gợi</a:t>
-            </a:r>
-            <a:r>
-              <a:rPr sz="4400" b="1" i="0" dirty="0">
-                <a:solidFill>
-                  <a:srgbClr val="FFFFFF"/>
-                </a:solidFill>
-                <a:latin typeface="Calibri"/>
-              </a:rPr>
-              <a:t> ý </a:t>
-            </a:r>
-            <a:r>
-              <a:rPr sz="4400" b="1" i="0" dirty="0" err="1">
-                <a:solidFill>
-                  <a:srgbClr val="FFFFFF"/>
-                </a:solidFill>
-                <a:latin typeface="Calibri"/>
-              </a:rPr>
-              <a:t>món</a:t>
-            </a:r>
-            <a:r>
-              <a:rPr sz="4400" b="1" i="0" dirty="0">
-                <a:solidFill>
-                  <a:srgbClr val="FFFFFF"/>
-                </a:solidFill>
-                <a:latin typeface="Calibri"/>
-              </a:rPr>
-              <a:t> </a:t>
-            </a:r>
-            <a:r>
-              <a:rPr sz="4400" b="1" i="0" dirty="0" err="1">
-                <a:solidFill>
-                  <a:srgbClr val="FFFFFF"/>
-                </a:solidFill>
-                <a:latin typeface="Calibri"/>
-              </a:rPr>
-              <a:t>ăn</a:t>
-            </a:r>
-            <a:r>
-              <a:rPr sz="4400" b="1" i="0" dirty="0">
-                <a:solidFill>
-                  <a:srgbClr val="FFFFFF"/>
-                </a:solidFill>
-                <a:latin typeface="Calibri"/>
-              </a:rPr>
-              <a:t> </a:t>
-            </a:r>
-            <a:r>
-              <a:rPr sz="4400" b="1" i="0" dirty="0" err="1">
-                <a:solidFill>
-                  <a:srgbClr val="FFFFFF"/>
-                </a:solidFill>
-                <a:latin typeface="Calibri"/>
-              </a:rPr>
-              <a:t>thông</a:t>
-            </a:r>
-            <a:r>
-              <a:rPr sz="4400" b="1" i="0" dirty="0">
-                <a:solidFill>
-                  <a:srgbClr val="FFFFFF"/>
-                </a:solidFill>
-                <a:latin typeface="Calibri"/>
-              </a:rPr>
-              <a:t> </a:t>
-            </a:r>
-            <a:r>
-              <a:rPr sz="4400" b="1" i="0" dirty="0" smtClean="0">
-                <a:solidFill>
-                  <a:srgbClr val="FFFFFF"/>
-                </a:solidFill>
-                <a:latin typeface="Calibri"/>
-              </a:rPr>
-              <a:t>minh</a:t>
-            </a:r>
-            <a:endParaRPr sz="4400" b="1" i="0" dirty="0">
-              <a:solidFill>
-                <a:srgbClr val="FFFFFF"/>
-              </a:solidFill>
-              <a:latin typeface="Calibri"/>
-            </a:endParaRPr>
+              <a:t>Food Moo Duu - Hệ thống gợi ý món ăn thông minh offline</a:t>
+            </a:r>
           </a:p>
           <a:p>
             <a:pPr>
@@ -3361,193 +3225,13 @@
               </a:spcBef>
             </a:pPr>
             <a:r>
-              <a:rPr sz="2000" b="0" i="1" dirty="0">
+              <a:rPr sz="2000" b="0" i="1">
                 <a:solidFill>
                   <a:srgbClr val="E86A17"/>
                 </a:solidFill>
                 <a:latin typeface="Calibri"/>
               </a:rPr>
-              <a:t>"</a:t>
-            </a:r>
-            <a:r>
-              <a:rPr sz="2000" b="0" i="1" dirty="0" err="1">
-                <a:solidFill>
-                  <a:srgbClr val="E86A17"/>
-                </a:solidFill>
-                <a:latin typeface="Calibri"/>
-              </a:rPr>
-              <a:t>Là</a:t>
-            </a:r>
-            <a:r>
-              <a:rPr sz="2000" b="0" i="1" dirty="0">
-                <a:solidFill>
-                  <a:srgbClr val="E86A17"/>
-                </a:solidFill>
-                <a:latin typeface="Calibri"/>
-              </a:rPr>
-              <a:t> </a:t>
-            </a:r>
-            <a:r>
-              <a:rPr sz="2000" b="0" i="1" dirty="0" err="1">
-                <a:solidFill>
-                  <a:srgbClr val="E86A17"/>
-                </a:solidFill>
-                <a:latin typeface="Calibri"/>
-              </a:rPr>
-              <a:t>bò</a:t>
-            </a:r>
-            <a:r>
-              <a:rPr sz="2000" b="0" i="1" dirty="0">
-                <a:solidFill>
-                  <a:srgbClr val="E86A17"/>
-                </a:solidFill>
-                <a:latin typeface="Calibri"/>
-              </a:rPr>
-              <a:t>, </a:t>
-            </a:r>
-            <a:r>
-              <a:rPr sz="2000" b="0" i="1" dirty="0" err="1">
-                <a:solidFill>
-                  <a:srgbClr val="E86A17"/>
-                </a:solidFill>
-                <a:latin typeface="Calibri"/>
-              </a:rPr>
-              <a:t>sáng</a:t>
-            </a:r>
-            <a:r>
-              <a:rPr sz="2000" b="0" i="1" dirty="0">
-                <a:solidFill>
-                  <a:srgbClr val="E86A17"/>
-                </a:solidFill>
-                <a:latin typeface="Calibri"/>
-              </a:rPr>
-              <a:t> </a:t>
-            </a:r>
-            <a:r>
-              <a:rPr sz="2000" b="0" i="1" dirty="0" err="1">
-                <a:solidFill>
-                  <a:srgbClr val="E86A17"/>
-                </a:solidFill>
-                <a:latin typeface="Calibri"/>
-              </a:rPr>
-              <a:t>phải</a:t>
-            </a:r>
-            <a:r>
-              <a:rPr sz="2000" b="0" i="1" dirty="0">
-                <a:solidFill>
-                  <a:srgbClr val="E86A17"/>
-                </a:solidFill>
-                <a:latin typeface="Calibri"/>
-              </a:rPr>
-              <a:t> </a:t>
-            </a:r>
-            <a:r>
-              <a:rPr sz="2000" b="0" i="1" dirty="0" err="1">
-                <a:solidFill>
-                  <a:srgbClr val="E86A17"/>
-                </a:solidFill>
-                <a:latin typeface="Calibri"/>
-              </a:rPr>
-              <a:t>rống</a:t>
-            </a:r>
-            <a:r>
-              <a:rPr sz="2000" b="0" i="1" dirty="0">
-                <a:solidFill>
-                  <a:srgbClr val="E86A17"/>
-                </a:solidFill>
-                <a:latin typeface="Calibri"/>
-              </a:rPr>
-              <a:t> - </a:t>
-            </a:r>
-            <a:r>
-              <a:rPr sz="2000" b="0" i="1" dirty="0" err="1">
-                <a:solidFill>
-                  <a:srgbClr val="E86A17"/>
-                </a:solidFill>
-                <a:latin typeface="Calibri"/>
-              </a:rPr>
-              <a:t>Là</a:t>
-            </a:r>
-            <a:r>
-              <a:rPr sz="2000" b="0" i="1" dirty="0">
-                <a:solidFill>
-                  <a:srgbClr val="E86A17"/>
-                </a:solidFill>
-                <a:latin typeface="Calibri"/>
-              </a:rPr>
-              <a:t> </a:t>
-            </a:r>
-            <a:r>
-              <a:rPr sz="2000" b="0" i="1" dirty="0" err="1">
-                <a:solidFill>
-                  <a:srgbClr val="E86A17"/>
-                </a:solidFill>
-                <a:latin typeface="Calibri"/>
-              </a:rPr>
-              <a:t>người</a:t>
-            </a:r>
-            <a:r>
-              <a:rPr sz="2000" b="0" i="1" dirty="0">
-                <a:solidFill>
-                  <a:srgbClr val="E86A17"/>
-                </a:solidFill>
-                <a:latin typeface="Calibri"/>
-              </a:rPr>
-              <a:t>, </a:t>
-            </a:r>
-            <a:r>
-              <a:rPr sz="2000" b="0" i="1" dirty="0" err="1">
-                <a:solidFill>
-                  <a:srgbClr val="E86A17"/>
-                </a:solidFill>
-                <a:latin typeface="Calibri"/>
-              </a:rPr>
-              <a:t>sống</a:t>
-            </a:r>
-            <a:r>
-              <a:rPr sz="2000" b="0" i="1" dirty="0">
-                <a:solidFill>
-                  <a:srgbClr val="E86A17"/>
-                </a:solidFill>
-                <a:latin typeface="Calibri"/>
-              </a:rPr>
-              <a:t> </a:t>
-            </a:r>
-            <a:r>
-              <a:rPr sz="2000" b="0" i="1" dirty="0" err="1">
-                <a:solidFill>
-                  <a:srgbClr val="E86A17"/>
-                </a:solidFill>
-                <a:latin typeface="Calibri"/>
-              </a:rPr>
-              <a:t>phải</a:t>
-            </a:r>
-            <a:r>
-              <a:rPr sz="2000" b="0" i="1" dirty="0">
-                <a:solidFill>
-                  <a:srgbClr val="E86A17"/>
-                </a:solidFill>
-                <a:latin typeface="Calibri"/>
-              </a:rPr>
-              <a:t> </a:t>
-            </a:r>
-            <a:r>
-              <a:rPr sz="2000" b="0" i="1" dirty="0" err="1">
-                <a:solidFill>
-                  <a:srgbClr val="E86A17"/>
-                </a:solidFill>
-                <a:latin typeface="Calibri"/>
-              </a:rPr>
-              <a:t>ráng</a:t>
-            </a:r>
-            <a:r>
-              <a:rPr sz="2000" b="0" i="1" dirty="0">
-                <a:solidFill>
-                  <a:srgbClr val="E86A17"/>
-                </a:solidFill>
-                <a:latin typeface="Calibri"/>
-              </a:rPr>
-              <a:t>"</a:t>
+              <a:t>"Là bò, sáng phải rống - Là người, sống phải ráng"</a:t>
             </a:r>
           </a:p>
         </p:txBody>
@@ -3561,7 +3245,7 @@
         <p:spPr>
           <a:xfrm>
             <a:off x="900000" y="4100000"/>
-            <a:ext cx="10400000" cy="1077218"/>
+            <a:ext cx="10400000" cy="1800000"/>
           </a:xfrm>
           <a:prstGeom prst="rect">
             <a:avLst/>
@@ -3575,328 +3259,46 @@
           <a:lstStyle/>
           <a:p>
             <a:r>
-              <a:rPr sz="1600" b="1" i="0" dirty="0" err="1">
+              <a:rPr sz="1600" b="1" i="0">
                 <a:solidFill>
                   <a:srgbClr val="127C8A"/>
                 </a:solidFill>
                 <a:latin typeface="Calibri"/>
               </a:rPr>
-              <a:t>Nhóm</a:t>
-            </a:r>
-            <a:r>
-              <a:rPr sz="1600" b="1" i="0" dirty="0">
-                <a:solidFill>
-                  <a:srgbClr val="127C8A"/>
-                </a:solidFill>
-                <a:latin typeface="Calibri"/>
-              </a:rPr>
-              <a:t> </a:t>
-            </a:r>
-            <a:r>
-              <a:rPr sz="1600" b="1" i="0" dirty="0" err="1">
-                <a:solidFill>
-                  <a:srgbClr val="127C8A"/>
-                </a:solidFill>
-                <a:latin typeface="Calibri"/>
-              </a:rPr>
-              <a:t>thực</a:t>
-            </a:r>
-            <a:r>
-              <a:rPr sz="1600" b="1" i="0" dirty="0">
-                <a:solidFill>
-                  <a:srgbClr val="127C8A"/>
-                </a:solidFill>
-                <a:latin typeface="Calibri"/>
-              </a:rPr>
-              <a:t> </a:t>
-            </a:r>
-            <a:r>
-              <a:rPr sz="1600" b="1" i="0" dirty="0" err="1">
-                <a:solidFill>
-                  <a:srgbClr val="127C8A"/>
-                </a:solidFill>
-                <a:latin typeface="Calibri"/>
-              </a:rPr>
-              <a:t>hiện</a:t>
-            </a:r>
-            <a:endParaRPr sz="1600" b="1" i="0" dirty="0">
-              <a:solidFill>
-                <a:srgbClr val="127C8A"/>
-              </a:solidFill>
-              <a:latin typeface="Calibri"/>
-            </a:endParaRPr>
-          </a:p>
-          <a:p>
-            <a:r>
-              <a:rPr sz="1600" b="0" i="0" dirty="0" err="1">
+              <a:t>Nhóm thực hiện</a:t>
+            </a:r>
+          </a:p>
+          <a:p>
+            <a:r>
+              <a:rPr sz="1600" b="0" i="0">
                 <a:solidFill>
                   <a:srgbClr val="F5F1E8"/>
                 </a:solidFill>
                 <a:latin typeface="Calibri"/>
               </a:rPr>
-              <a:t>Trần</a:t>
-            </a:r>
-            <a:r>
-              <a:rPr sz="1600" b="0" i="0" dirty="0">
+              <a:t>Trần Việt Hoàng  -  Layer 1 - Định nghĩa Tag + Kiến trúc tổng thể</a:t>
+            </a:r>
+          </a:p>
+          <a:p>
+            <a:r>
+              <a:rPr sz="1600" b="0" i="0">
                 <a:solidFill>
                   <a:srgbClr val="F5F1E8"/>
                 </a:solidFill>
                 <a:latin typeface="Calibri"/>
               </a:rPr>
-              <a:t> </a:t>
-            </a:r>
-            <a:r>
-              <a:rPr sz="1600" b="0" i="0" dirty="0" err="1">
+              <a:t>Bùi Đức Anh  -  Layer 2 - Adaptive Recommendation</a:t>
+            </a:r>
+          </a:p>
+          <a:p>
+            <a:r>
+              <a:rPr sz="1600" b="0" i="0">
                 <a:solidFill>
                   <a:srgbClr val="F5F1E8"/>
                 </a:solidFill>
                 <a:latin typeface="Calibri"/>
               </a:rPr>
-              <a:t>Việt</a:t>
-            </a:r>
-            <a:r>
-              <a:rPr sz="1600" b="0" i="0" dirty="0">
-                <a:solidFill>
-                  <a:srgbClr val="F5F1E8"/>
-                </a:solidFill>
-                <a:latin typeface="Calibri"/>
-              </a:rPr>
-              <a:t> </a:t>
-            </a:r>
-            <a:r>
-              <a:rPr sz="1600" b="0" i="0" dirty="0" err="1">
-                <a:solidFill>
-                  <a:srgbClr val="F5F1E8"/>
-                </a:solidFill>
-                <a:latin typeface="Calibri"/>
-              </a:rPr>
-              <a:t>Hoàng</a:t>
-            </a:r>
-            <a:r>
-              <a:rPr sz="1600" b="0" i="0" dirty="0">
-                <a:solidFill>
-                  <a:srgbClr val="F5F1E8"/>
-                </a:solidFill>
-                <a:latin typeface="Calibri"/>
-              </a:rPr>
-              <a:t>  -  Layer 1 </a:t>
-            </a:r>
-            <a:r>
-              <a:rPr lang="en-US" sz="1600" b="0" i="0" dirty="0" smtClean="0">
-                <a:solidFill>
-                  <a:srgbClr val="F5F1E8"/>
-                </a:solidFill>
-                <a:latin typeface="Calibri"/>
-              </a:rPr>
-              <a:t>–</a:t>
-            </a:r>
-            <a:r>
-              <a:rPr sz="1600" b="0" i="0" dirty="0" smtClean="0">
-                <a:solidFill>
-                  <a:srgbClr val="F5F1E8"/>
-                </a:solidFill>
-                <a:latin typeface="Calibri"/>
-              </a:rPr>
-              <a:t> Tag</a:t>
-            </a:r>
-            <a:r>
-              <a:rPr lang="en-US" sz="1600" b="0" i="0" dirty="0" smtClean="0">
-                <a:solidFill>
-                  <a:srgbClr val="F5F1E8"/>
-                </a:solidFill>
-                <a:latin typeface="Calibri"/>
-              </a:rPr>
-              <a:t> </a:t>
-            </a:r>
-            <a:r>
-              <a:rPr lang="en-US" sz="1600" b="0" i="0" dirty="0" err="1" smtClean="0">
-                <a:solidFill>
-                  <a:srgbClr val="F5F1E8"/>
-                </a:solidFill>
-                <a:latin typeface="Calibri"/>
-              </a:rPr>
-              <a:t>Detech</a:t>
-            </a:r>
-            <a:r>
-              <a:rPr sz="1600" b="0" i="0" dirty="0" smtClean="0">
-                <a:solidFill>
-                  <a:srgbClr val="F5F1E8"/>
-                </a:solidFill>
-                <a:latin typeface="Calibri"/>
-              </a:rPr>
-              <a:t> </a:t>
-            </a:r>
-            <a:r>
-              <a:rPr sz="1600" b="0" i="0" dirty="0">
-                <a:solidFill>
-                  <a:srgbClr val="F5F1E8"/>
-                </a:solidFill>
-                <a:latin typeface="Calibri"/>
-              </a:rPr>
-              <a:t>+ </a:t>
-            </a:r>
-            <a:r>
-              <a:rPr sz="1600" b="0" i="0" dirty="0" err="1">
-                <a:solidFill>
-                  <a:srgbClr val="F5F1E8"/>
-                </a:solidFill>
-                <a:latin typeface="Calibri"/>
-              </a:rPr>
-              <a:t>Kiến</a:t>
-            </a:r>
-            <a:r>
-              <a:rPr sz="1600" b="0" i="0" dirty="0">
-                <a:solidFill>
-                  <a:srgbClr val="F5F1E8"/>
-                </a:solidFill>
-                <a:latin typeface="Calibri"/>
-              </a:rPr>
-              <a:t> </a:t>
-            </a:r>
-            <a:r>
-              <a:rPr sz="1600" b="0" i="0" dirty="0" err="1">
-                <a:solidFill>
-                  <a:srgbClr val="F5F1E8"/>
-                </a:solidFill>
-                <a:latin typeface="Calibri"/>
-              </a:rPr>
-              <a:t>trúc</a:t>
-            </a:r>
-            <a:r>
-              <a:rPr sz="1600" b="0" i="0" dirty="0">
-                <a:solidFill>
-                  <a:srgbClr val="F5F1E8"/>
-                </a:solidFill>
-                <a:latin typeface="Calibri"/>
-              </a:rPr>
-              <a:t> </a:t>
-            </a:r>
-            <a:r>
-              <a:rPr sz="1600" b="0" i="0" dirty="0" err="1">
-                <a:solidFill>
-                  <a:srgbClr val="F5F1E8"/>
-                </a:solidFill>
-                <a:latin typeface="Calibri"/>
-              </a:rPr>
-              <a:t>tổng</a:t>
-            </a:r>
-            <a:r>
-              <a:rPr sz="1600" b="0" i="0" dirty="0">
-                <a:solidFill>
-                  <a:srgbClr val="F5F1E8"/>
-                </a:solidFill>
-                <a:latin typeface="Calibri"/>
-              </a:rPr>
-              <a:t> </a:t>
-            </a:r>
-            <a:r>
-              <a:rPr sz="1600" b="0" i="0" dirty="0" err="1">
-                <a:solidFill>
-                  <a:srgbClr val="F5F1E8"/>
-                </a:solidFill>
-                <a:latin typeface="Calibri"/>
-              </a:rPr>
-              <a:t>thể</a:t>
-            </a:r>
-            <a:endParaRPr sz="1600" b="0" i="0" dirty="0">
-              <a:solidFill>
-                <a:srgbClr val="F5F1E8"/>
-              </a:solidFill>
-              <a:latin typeface="Calibri"/>
-            </a:endParaRPr>
-          </a:p>
-          <a:p>
-            <a:r>
-              <a:rPr sz="1600" b="0" i="0" dirty="0" err="1">
-                <a:solidFill>
-                  <a:srgbClr val="F5F1E8"/>
-                </a:solidFill>
-                <a:latin typeface="Calibri"/>
-              </a:rPr>
-              <a:t>Bùi</a:t>
-            </a:r>
-            <a:r>
-              <a:rPr sz="1600" b="0" i="0" dirty="0">
-                <a:solidFill>
-                  <a:srgbClr val="F5F1E8"/>
-                </a:solidFill>
-                <a:latin typeface="Calibri"/>
-              </a:rPr>
-              <a:t> </a:t>
-            </a:r>
-            <a:r>
-              <a:rPr sz="1600" b="0" i="0" dirty="0" err="1">
-                <a:solidFill>
-                  <a:srgbClr val="F5F1E8"/>
-                </a:solidFill>
-                <a:latin typeface="Calibri"/>
-              </a:rPr>
-              <a:t>Đức</a:t>
-            </a:r>
-            <a:r>
-              <a:rPr sz="1600" b="0" i="0" dirty="0">
-                <a:solidFill>
-                  <a:srgbClr val="F5F1E8"/>
-                </a:solidFill>
-                <a:latin typeface="Calibri"/>
-              </a:rPr>
-              <a:t> </a:t>
-            </a:r>
-            <a:r>
-              <a:rPr sz="1600" b="0" i="0" dirty="0" err="1">
-                <a:solidFill>
-                  <a:srgbClr val="F5F1E8"/>
-                </a:solidFill>
-                <a:latin typeface="Calibri"/>
-              </a:rPr>
-              <a:t>Anh</a:t>
-            </a:r>
-            <a:r>
-              <a:rPr sz="1600" b="0" i="0" dirty="0">
-                <a:solidFill>
-                  <a:srgbClr val="F5F1E8"/>
-                </a:solidFill>
-                <a:latin typeface="Calibri"/>
-              </a:rPr>
-              <a:t>  -  Layer 2 - Adaptive Recommendation</a:t>
-            </a:r>
-          </a:p>
-          <a:p>
-            <a:r>
-              <a:rPr sz="1600" b="0" i="0" dirty="0" err="1">
-                <a:solidFill>
-                  <a:srgbClr val="F5F1E8"/>
-                </a:solidFill>
-                <a:latin typeface="Calibri"/>
-              </a:rPr>
-              <a:t>Trần</a:t>
-            </a:r>
-            <a:r>
-              <a:rPr sz="1600" b="0" i="0" dirty="0">
-                <a:solidFill>
-                  <a:srgbClr val="F5F1E8"/>
-                </a:solidFill>
-                <a:latin typeface="Calibri"/>
-              </a:rPr>
-              <a:t> </a:t>
-            </a:r>
-            <a:r>
-              <a:rPr sz="1600" b="0" i="0" dirty="0" err="1">
-                <a:solidFill>
-                  <a:srgbClr val="F5F1E8"/>
-                </a:solidFill>
-                <a:latin typeface="Calibri"/>
-              </a:rPr>
-              <a:t>Bình</a:t>
-            </a:r>
-            <a:r>
-              <a:rPr sz="1600" b="0" i="0" dirty="0">
-                <a:solidFill>
-                  <a:srgbClr val="F5F1E8"/>
-                </a:solidFill>
-                <a:latin typeface="Calibri"/>
-              </a:rPr>
-              <a:t> Minh  -  Layer 3 - Genetic Response</a:t>
+              <a:t>Trần Bình Minh  -  Layer 3 - Genetic Response</a:t>
             </a:r>
           </a:p>
         </p:txBody>
@@ -4147,8 +3549,8 @@
         </p:blipFill>
         <p:spPr>
           <a:xfrm>
-            <a:off x="2492969" y="2799184"/>
-            <a:ext cx="7214061" cy="3900816"/>
+            <a:off x="2415318" y="2715208"/>
+            <a:ext cx="7369364" cy="3984792"/>
           </a:xfrm>
           <a:prstGeom prst="rect">
             <a:avLst/>
@@ -5103,8 +4505,8 @@
         </p:blipFill>
         <p:spPr>
           <a:xfrm>
-            <a:off x="2445752" y="2748121"/>
-            <a:ext cx="7308496" cy="3951879"/>
+            <a:off x="2216876" y="2500604"/>
+            <a:ext cx="7766247" cy="4199396"/>
           </a:xfrm>
           <a:prstGeom prst="rect">
             <a:avLst/>
@@ -5971,7 +5373,7 @@
     <p:bg>
       <p:bgPr>
         <a:solidFill>
-          <a:srgbClr val="F5F1E8"/>
+          <a:srgbClr val="127C8A"/>
         </a:solidFill>
         <a:effectLst/>
       </p:bgPr>
@@ -6042,8 +5444,8 @@
         </p:nvSpPr>
         <p:spPr>
           <a:xfrm>
-            <a:off x="500000" y="350000"/>
-            <a:ext cx="9800000" cy="900000"/>
+            <a:off x="900000" y="2600000"/>
+            <a:ext cx="10400000" cy="1600000"/>
           </a:xfrm>
           <a:prstGeom prst="rect">
             <a:avLst/>
@@ -6051,190 +5453,30 @@
           <a:noFill/>
         </p:spPr>
         <p:txBody>
-          <a:bodyPr wrap="square">
+          <a:bodyPr wrap="square" anchor="ctr">
             <a:spAutoFit/>
           </a:bodyPr>
           <a:lstStyle/>
           <a:p>
             <a:r>
-              <a:rPr sz="3000" b="1" i="0">
-                <a:solidFill>
-                  <a:srgbClr val="1F2D3D"/>
-                </a:solidFill>
-                <a:latin typeface="Calibri"/>
-              </a:rPr>
-              <a:t>Triển khai &amp; DevOps</a:t>
-            </a:r>
-          </a:p>
-        </p:txBody>
-      </p:sp>
-      <p:sp>
-        <p:nvSpPr>
-          <p:cNvPr id="4" name="Rectangle 3"/>
-          <p:cNvSpPr/>
-          <p:nvPr/>
-        </p:nvSpPr>
-        <p:spPr>
-          <a:xfrm>
-            <a:off x="9400000" y="380000"/>
-            <a:ext cx="2400000" cy="520000"/>
-          </a:xfrm>
-          <a:prstGeom prst="rect">
-            <a:avLst/>
-          </a:prstGeom>
-          <a:solidFill>
-            <a:srgbClr val="127C8A"/>
-          </a:solidFill>
-          <a:ln>
-            <a:noFill/>
-          </a:ln>
-        </p:spPr>
-        <p:style>
-          <a:lnRef idx="1">
-            <a:schemeClr val="accent1"/>
-          </a:lnRef>
-          <a:fillRef idx="3">
-            <a:schemeClr val="accent1"/>
-          </a:fillRef>
-          <a:effectRef idx="2">
-            <a:schemeClr val="accent1"/>
-          </a:effectRef>
-          <a:fontRef idx="minor">
-            <a:schemeClr val="lt1"/>
-          </a:fontRef>
-        </p:style>
-        <p:txBody>
-          <a:bodyPr wrap="square" rtlCol="0" anchor="ctr"/>
-          <a:lstStyle/>
-          <a:p>
-            <a:pPr algn="ctr"/>
-            <a:r>
-              <a:rPr sz="1200" b="1" i="0">
+              <a:rPr sz="3600" b="1" i="0">
                 <a:solidFill>
                   <a:srgbClr val="FFFFFF"/>
                 </a:solidFill>
                 <a:latin typeface="Calibri"/>
               </a:rPr>
-              <a:t>Đức Anh</a:t>
-            </a:r>
-          </a:p>
-        </p:txBody>
-      </p:sp>
-      <p:sp>
-        <p:nvSpPr>
-          <p:cNvPr id="5" name="TextBox 4"/>
-          <p:cNvSpPr txBox="1"/>
-          <p:nvPr/>
-        </p:nvSpPr>
-        <p:spPr>
-          <a:xfrm>
-            <a:off x="600000" y="1450000"/>
-            <a:ext cx="11000000" cy="5000000"/>
-          </a:xfrm>
-          <a:prstGeom prst="rect">
-            <a:avLst/>
-          </a:prstGeom>
-          <a:noFill/>
-        </p:spPr>
-        <p:txBody>
-          <a:bodyPr wrap="square">
-            <a:spAutoFit/>
-          </a:bodyPr>
-          <a:lstStyle/>
-          <a:p>
-            <a:pPr>
-              <a:spcBef>
-                <a:spcPts val="1000"/>
-              </a:spcBef>
-            </a:pPr>
-            <a:r>
-              <a:rPr sz="1900" b="1" i="0">
-                <a:solidFill>
-                  <a:srgbClr val="E86A17"/>
-                </a:solidFill>
-                <a:latin typeface="Calibri"/>
-              </a:rPr>
-              <a:t>Makefile - một lệnh cho mỗi tác vụ</a:t>
-            </a:r>
-          </a:p>
-          <a:p>
-            <a:pPr>
-              <a:spcBef>
-                <a:spcPts val="500"/>
-              </a:spcBef>
-            </a:pPr>
-            <a:r>
-              <a:rPr sz="1600" b="0" i="0">
-                <a:solidFill>
-                  <a:srgbClr val="1F2D3D"/>
-                </a:solidFill>
-                <a:latin typeface="Calibri"/>
-              </a:rPr>
-              <a:t>•  make setup | app-run | app-demo | layer{1,2,3}-*</a:t>
-            </a:r>
-          </a:p>
-          <a:p>
-            <a:pPr>
-              <a:spcBef>
-                <a:spcPts val="1000"/>
-              </a:spcBef>
-            </a:pPr>
-            <a:r>
-              <a:rPr sz="1900" b="1" i="0">
-                <a:solidFill>
-                  <a:srgbClr val="E86A17"/>
-                </a:solidFill>
-                <a:latin typeface="Calibri"/>
-              </a:rPr>
-              <a:t>Docker</a:t>
-            </a:r>
-          </a:p>
-          <a:p>
-            <a:pPr>
-              <a:spcBef>
-                <a:spcPts val="500"/>
-              </a:spcBef>
-            </a:pPr>
-            <a:r>
-              <a:rPr sz="1600" b="0" i="0">
-                <a:solidFill>
-                  <a:srgbClr val="1F2D3D"/>
-                </a:solidFill>
-                <a:latin typeface="Calibri"/>
-              </a:rPr>
-              <a:t>•  docker/layer1|2|3/docker-compose.yml + docker/app/ (full app)</a:t>
-            </a:r>
-          </a:p>
-          <a:p>
-            <a:pPr>
-              <a:spcBef>
-                <a:spcPts val="1000"/>
-              </a:spcBef>
-            </a:pPr>
-            <a:r>
-              <a:rPr sz="1900" b="1" i="0">
-                <a:solidFill>
-                  <a:srgbClr val="E86A17"/>
-                </a:solidFill>
-                <a:latin typeface="Calibri"/>
-              </a:rPr>
-              <a:t>Testing</a:t>
-            </a:r>
-          </a:p>
-          <a:p>
-            <a:pPr>
-              <a:spcBef>
-                <a:spcPts val="500"/>
-              </a:spcBef>
-            </a:pPr>
-            <a:r>
-              <a:rPr sz="1600" b="0" i="0">
-                <a:solidFill>
-                  <a:srgbClr val="1F2D3D"/>
-                </a:solidFill>
-                <a:latin typeface="Calibri"/>
-              </a:rPr>
-              <a:t>•  test_layer2.py, test_layer2_integration.py, test_feedback_logging.py</a:t>
+              <a:t>Đánh giá hiệu quả</a:t>
+            </a:r>
+          </a:p>
+          <a:p>
+            <a:r>
+              <a:rPr sz="1800" b="0" i="1">
+                <a:solidFill>
+                  <a:srgbClr val="F5F1E8"/>
+                </a:solidFill>
+                <a:latin typeface="Calibri"/>
+              </a:rPr>
+              <a:t>Phụ trách: Cả nhóm</a:t>
             </a:r>
           </a:p>
         </p:txBody>
@@ -6345,7 +5587,7 @@
                 </a:solidFill>
                 <a:latin typeface="Calibri"/>
               </a:rPr>
-              <a:t>Demo minh họa</a:t>
+              <a:t>Pipeline đánh giá &amp; phương pháp</a:t>
             </a:r>
           </a:p>
         </p:txBody>
@@ -6397,7 +5639,7 @@
                 </a:solidFill>
                 <a:latin typeface="Calibri"/>
               </a:rPr>
-              <a:t>Minh</a:t>
+              <a:t>Hoàng</a:t>
             </a:r>
           </a:p>
         </p:txBody>
@@ -6436,55 +5678,55 @@
                 </a:solidFill>
                 <a:latin typeface="Calibri"/>
               </a:rPr>
-              <a:t>Ví dụ non-interactive (make app-demo)</a:t>
-            </a:r>
-          </a:p>
-          <a:p>
-            <a:pPr lvl="1"/>
-            <a:r>
-              <a:rPr sz="1400" b="0" i="0">
-                <a:solidFill>
-                  <a:srgbClr val="555B66"/>
-                </a:solidFill>
-                <a:latin typeface="Calibri"/>
-              </a:rPr>
-              <a:t>–  Chat 1: 'Tối nay trời lạnh, tôi muốn món nước nóng'</a:t>
-            </a:r>
-          </a:p>
-          <a:p>
-            <a:pPr lvl="1"/>
-            <a:r>
-              <a:rPr sz="1400" b="0" i="0">
-                <a:solidFill>
-                  <a:srgbClr val="555B66"/>
-                </a:solidFill>
-                <a:latin typeface="Calibri"/>
-              </a:rPr>
-              <a:t>–  Bot: câu trả lời genetic + Top 5 món + score</a:t>
-            </a:r>
-          </a:p>
-          <a:p>
-            <a:pPr lvl="1"/>
-            <a:r>
-              <a:rPr sz="1400" b="0" i="0">
-                <a:solidFill>
-                  <a:srgbClr val="555B66"/>
-                </a:solidFill>
-                <a:latin typeface="Calibri"/>
-              </a:rPr>
-              <a:t>–  Chat 2..5: 'Quay xe, giờ tôi muốn món nhanh và tiện lợi'</a:t>
-            </a:r>
-          </a:p>
-          <a:p>
-            <a:pPr lvl="1"/>
-            <a:r>
-              <a:rPr sz="1400" b="0" i="0">
-                <a:solidFill>
-                  <a:srgbClr val="555B66"/>
-                </a:solidFill>
-                <a:latin typeface="Calibri"/>
-              </a:rPr>
-              <a:t>–  Feedback: chosen=dish_001 -&gt; delta score</a:t>
+              <a:t>Package: src/evaluation/ (metrics, layer1/2/3_eval, pipeline_eval)</a:t>
+            </a:r>
+          </a:p>
+          <a:p>
+            <a:pPr>
+              <a:spcBef>
+                <a:spcPts val="500"/>
+              </a:spcBef>
+            </a:pPr>
+            <a:r>
+              <a:rPr sz="1600" b="0" i="0">
+                <a:solidFill>
+                  <a:srgbClr val="1F2D3D"/>
+                </a:solidFill>
+                <a:latin typeface="Calibri"/>
+              </a:rPr>
+              <a:t>•  make layer3-simulate — bổ sung data giả lập L3</a:t>
+            </a:r>
+          </a:p>
+          <a:p>
+            <a:pPr>
+              <a:spcBef>
+                <a:spcPts val="500"/>
+              </a:spcBef>
+            </a:pPr>
+            <a:r>
+              <a:rPr sz="1600" b="0" i="0">
+                <a:solidFill>
+                  <a:srgbClr val="1F2D3D"/>
+                </a:solidFill>
+                <a:latin typeface="Calibri"/>
+              </a:rPr>
+              <a:t>•  make eval-run — đánh giá toàn bộ (skip train L1)</a:t>
+            </a:r>
+          </a:p>
+          <a:p>
+            <a:pPr>
+              <a:spcBef>
+                <a:spcPts val="500"/>
+              </a:spcBef>
+            </a:pPr>
+            <a:r>
+              <a:rPr sz="1600" b="0" i="0">
+                <a:solidFill>
+                  <a:srgbClr val="1F2D3D"/>
+                </a:solidFill>
+                <a:latin typeface="Calibri"/>
+              </a:rPr>
+              <a:t>•  make eval-train-and-run — train ablation L1 + đánh giá</a:t>
             </a:r>
           </a:p>
           <a:p>
@@ -6500,7 +5742,7 @@
                 </a:solidFill>
                 <a:latin typeface="Calibri"/>
               </a:rPr>
-              <a:t>Điểm cần nhấn</a:t>
+              <a:t>Tập dữ liệu đánh giá</a:t>
             </a:r>
           </a:p>
           <a:p>
@@ -6516,7 +5758,71 @@
                 </a:solidFill>
                 <a:latin typeface="Calibri"/>
               </a:rPr>
-              <a:t>•  DST xử lý 'quay xe' | score món đổi sau feedback | câu trả lời theo mood</a:t>
+              <a:t>•  L1: validation 20% intent (all datasets) — 142 mẫu</a:t>
+            </a:r>
+          </a:p>
+          <a:p>
+            <a:pPr>
+              <a:spcBef>
+                <a:spcPts val="500"/>
+              </a:spcBef>
+            </a:pPr>
+            <a:r>
+              <a:rPr sz="1600" b="0" i="0">
+                <a:solidFill>
+                  <a:srgbClr val="1F2D3D"/>
+                </a:solidFill>
+                <a:latin typeface="Calibri"/>
+              </a:rPr>
+              <a:t>•  L2 Oracle: intent_samples.csv tag lý tưởng — 709 mẫu</a:t>
+            </a:r>
+          </a:p>
+          <a:p>
+            <a:pPr>
+              <a:spcBef>
+                <a:spcPts val="500"/>
+              </a:spcBef>
+            </a:pPr>
+            <a:r>
+              <a:rPr sz="1600" b="0" i="0">
+                <a:solidFill>
+                  <a:srgbClr val="1F2D3D"/>
+                </a:solidFill>
+                <a:latin typeface="Calibri"/>
+              </a:rPr>
+              <a:t>•  L2 Behavioral: RL events (4 runtime + 100 simulated) — 104 events</a:t>
+            </a:r>
+          </a:p>
+          <a:p>
+            <a:pPr>
+              <a:spcBef>
+                <a:spcPts val="500"/>
+              </a:spcBef>
+            </a:pPr>
+            <a:r>
+              <a:rPr sz="1600" b="0" i="0">
+                <a:solidFill>
+                  <a:srgbClr val="1F2D3D"/>
+                </a:solidFill>
+                <a:latin typeface="Calibri"/>
+              </a:rPr>
+              <a:t>•  L3: fitness_history (11 runtime + 50 simulated) — 61 lượt</a:t>
+            </a:r>
+          </a:p>
+          <a:p>
+            <a:pPr>
+              <a:spcBef>
+                <a:spcPts val="800"/>
+              </a:spcBef>
+            </a:pPr>
+            <a:r>
+              <a:rPr sz="1300" b="0" i="1">
+                <a:solidFill>
+                  <a:srgbClr val="127C8A"/>
+                </a:solidFill>
+                <a:latin typeface="Calibri"/>
+              </a:rPr>
+              <a:t>Metric: F1 (L1), Hit@K/MRR/NDCG (L2), success rate/fitness (L3), feedback delta</a:t>
             </a:r>
           </a:p>
         </p:txBody>
@@ -6920,8 +6226,8 @@
         </p:nvSpPr>
         <p:spPr>
           <a:xfrm>
-            <a:off x="500000" y="350000"/>
-            <a:ext cx="9800000" cy="900000"/>
+            <a:off x="500000" y="300000"/>
+            <a:ext cx="9800000" cy="850000"/>
           </a:xfrm>
           <a:prstGeom prst="rect">
             <a:avLst/>
@@ -6935,13 +6241,13 @@
           <a:lstStyle/>
           <a:p>
             <a:r>
-              <a:rPr sz="3000" b="1" i="0">
+              <a:rPr sz="2600" b="1" i="0">
                 <a:solidFill>
                   <a:srgbClr val="1F2D3D"/>
                 </a:solidFill>
                 <a:latin typeface="Calibri"/>
               </a:rPr>
-              <a:t>Đánh giá, Hạn chế &amp; Kết luận</a:t>
+              <a:t>Kết quả đánh giá tổng hợp</a:t>
             </a:r>
           </a:p>
         </p:txBody>
@@ -6954,7 +6260,7 @@
         </p:nvSpPr>
         <p:spPr>
           <a:xfrm>
-            <a:off x="9400000" y="380000"/>
+            <a:off x="9400000" y="330000"/>
             <a:ext cx="2400000" cy="520000"/>
           </a:xfrm>
           <a:prstGeom prst="rect">
@@ -6982,7 +6288,7 @@
           </a:fontRef>
         </p:style>
         <p:txBody>
-          <a:bodyPr wrap="square" rtlCol="0" anchor="ctr"/>
+          <a:bodyPr rtlCol="0" anchor="ctr"/>
           <a:lstStyle/>
           <a:p>
             <a:pPr algn="ctr"/>
@@ -7006,8 +6312,8 @@
         </p:nvSpPr>
         <p:spPr>
           <a:xfrm>
-            <a:off x="600000" y="1450000"/>
-            <a:ext cx="11000000" cy="5000000"/>
+            <a:off x="600000" y="1250000"/>
+            <a:ext cx="11000000" cy="1900000"/>
           </a:xfrm>
           <a:prstGeom prst="rect">
             <a:avLst/>
@@ -7020,6 +6326,260 @@
           </a:bodyPr>
           <a:lstStyle/>
           <a:p>
+            <a:r>
+              <a:rPr sz="1500" b="1" i="0">
+                <a:solidFill>
+                  <a:srgbClr val="E86A17"/>
+                </a:solidFill>
+                <a:latin typeface="Calibri"/>
+              </a:rPr>
+              <a:t>Run: 20260610_004458 | Chi tiết: docs/evaluation_metrics.md</a:t>
+            </a:r>
+          </a:p>
+          <a:p>
+            <a:r>
+              <a:rPr sz="1300" b="0" i="0">
+                <a:solidFill>
+                  <a:srgbClr val="1F2D3D"/>
+                </a:solidFill>
+                <a:latin typeface="Calibri"/>
+              </a:rPr>
+              <a:t>•  L1 Macro F1 = 0.189 | L2 Oracle Hit@5 = 1.0 | L2 Behavioral Hit@5 = 0.039</a:t>
+            </a:r>
+          </a:p>
+          <a:p>
+            <a:r>
+              <a:rPr sz="1300" b="0" i="0">
+                <a:solidFill>
+                  <a:srgbClr val="1F2D3D"/>
+                </a:solidFill>
+                <a:latin typeface="Calibri"/>
+              </a:rPr>
+              <a:t>•  L3 Success rate = 52.5% (61 lượt) | E2E Hit@5 = 0.039 | Feedback delta = +0.647</a:t>
+            </a:r>
+          </a:p>
+          <a:p>
+            <a:r>
+              <a:rPr sz="1200" b="0" i="1">
+                <a:solidFill>
+                  <a:srgbClr val="127C8A"/>
+                </a:solidFill>
+                <a:latin typeface="Calibri"/>
+              </a:rPr>
+              <a:t>Oracle cao -&gt; scoring tốt khi tag chuẩn; behavioral thấp -&gt; context runtime khó hơn</a:t>
+            </a:r>
+          </a:p>
+        </p:txBody>
+      </p:sp>
+      <p:pic>
+        <p:nvPicPr>
+          <p:cNvPr id="6" name="Picture 5" descr="evaluation_metrics.png"/>
+          <p:cNvPicPr>
+            <a:picLocks noChangeAspect="1"/>
+          </p:cNvPicPr>
+          <p:nvPr/>
+        </p:nvPicPr>
+        <p:blipFill>
+          <a:blip r:embed="rId2"/>
+          <a:stretch>
+            <a:fillRect/>
+          </a:stretch>
+        </p:blipFill>
+        <p:spPr>
+          <a:xfrm>
+            <a:off x="1832761" y="2436370"/>
+            <a:ext cx="8534477" cy="4351662"/>
+          </a:xfrm>
+          <a:prstGeom prst="rect">
+            <a:avLst/>
+          </a:prstGeom>
+        </p:spPr>
+      </p:pic>
+    </p:spTree>
+  </p:cSld>
+  <p:clrMapOvr>
+    <a:masterClrMapping/>
+  </p:clrMapOvr>
+</p:sld>
+</file>
+
+<file path=ppt/slides/slide21.xml><?xml version="1.0" encoding="utf-8"?>
+<p:sld xmlns:a="http://schemas.openxmlformats.org/drawingml/2006/main" xmlns:r="http://schemas.openxmlformats.org/officeDocument/2006/relationships" xmlns:p="http://schemas.openxmlformats.org/presentationml/2006/main">
+  <p:cSld>
+    <p:bg>
+      <p:bgPr>
+        <a:solidFill>
+          <a:srgbClr val="F5F1E8"/>
+        </a:solidFill>
+        <a:effectLst/>
+      </p:bgPr>
+    </p:bg>
+    <p:spTree>
+      <p:nvGrpSpPr>
+        <p:cNvPr id="1" name=""/>
+        <p:cNvGrpSpPr/>
+        <p:nvPr/>
+      </p:nvGrpSpPr>
+      <p:grpSpPr>
+        <a:xfrm>
+          <a:off x="0" y="0"/>
+          <a:ext cx="0" cy="0"/>
+          <a:chOff x="0" y="0"/>
+          <a:chExt cx="0" cy="0"/>
+        </a:xfrm>
+      </p:grpSpPr>
+      <p:sp>
+        <p:nvSpPr>
+          <p:cNvPr id="2" name="Rectangle 1"/>
+          <p:cNvSpPr/>
+          <p:nvPr/>
+        </p:nvSpPr>
+        <p:spPr>
+          <a:xfrm>
+            <a:off x="0" y="0"/>
+            <a:ext cx="160000" cy="6858000"/>
+          </a:xfrm>
+          <a:prstGeom prst="rect">
+            <a:avLst/>
+          </a:prstGeom>
+          <a:solidFill>
+            <a:srgbClr val="E86A17"/>
+          </a:solidFill>
+          <a:ln>
+            <a:noFill/>
+          </a:ln>
+        </p:spPr>
+        <p:style>
+          <a:lnRef idx="1">
+            <a:schemeClr val="accent1"/>
+          </a:lnRef>
+          <a:fillRef idx="3">
+            <a:schemeClr val="accent1"/>
+          </a:fillRef>
+          <a:effectRef idx="2">
+            <a:schemeClr val="accent1"/>
+          </a:effectRef>
+          <a:fontRef idx="minor">
+            <a:schemeClr val="lt1"/>
+          </a:fontRef>
+        </p:style>
+        <p:txBody>
+          <a:bodyPr rtlCol="0" anchor="ctr"/>
+          <a:lstStyle/>
+          <a:p>
+            <a:pPr algn="ctr"/>
+            <a:endParaRPr/>
+          </a:p>
+        </p:txBody>
+      </p:sp>
+      <p:sp>
+        <p:nvSpPr>
+          <p:cNvPr id="3" name="TextBox 2"/>
+          <p:cNvSpPr txBox="1"/>
+          <p:nvPr/>
+        </p:nvSpPr>
+        <p:spPr>
+          <a:xfrm>
+            <a:off x="500000" y="350000"/>
+            <a:ext cx="9800000" cy="900000"/>
+          </a:xfrm>
+          <a:prstGeom prst="rect">
+            <a:avLst/>
+          </a:prstGeom>
+          <a:noFill/>
+        </p:spPr>
+        <p:txBody>
+          <a:bodyPr wrap="square">
+            <a:spAutoFit/>
+          </a:bodyPr>
+          <a:lstStyle/>
+          <a:p>
+            <a:r>
+              <a:rPr sz="3000" b="1" i="0">
+                <a:solidFill>
+                  <a:srgbClr val="1F2D3D"/>
+                </a:solidFill>
+                <a:latin typeface="Calibri"/>
+              </a:rPr>
+              <a:t>Chi tiết metric từng layer</a:t>
+            </a:r>
+          </a:p>
+        </p:txBody>
+      </p:sp>
+      <p:sp>
+        <p:nvSpPr>
+          <p:cNvPr id="4" name="Rectangle 3"/>
+          <p:cNvSpPr/>
+          <p:nvPr/>
+        </p:nvSpPr>
+        <p:spPr>
+          <a:xfrm>
+            <a:off x="9400000" y="380000"/>
+            <a:ext cx="2400000" cy="520000"/>
+          </a:xfrm>
+          <a:prstGeom prst="rect">
+            <a:avLst/>
+          </a:prstGeom>
+          <a:solidFill>
+            <a:srgbClr val="127C8A"/>
+          </a:solidFill>
+          <a:ln>
+            <a:noFill/>
+          </a:ln>
+        </p:spPr>
+        <p:style>
+          <a:lnRef idx="1">
+            <a:schemeClr val="accent1"/>
+          </a:lnRef>
+          <a:fillRef idx="3">
+            <a:schemeClr val="accent1"/>
+          </a:fillRef>
+          <a:effectRef idx="2">
+            <a:schemeClr val="accent1"/>
+          </a:effectRef>
+          <a:fontRef idx="minor">
+            <a:schemeClr val="lt1"/>
+          </a:fontRef>
+        </p:style>
+        <p:txBody>
+          <a:bodyPr wrap="square" rtlCol="0" anchor="ctr"/>
+          <a:lstStyle/>
+          <a:p>
+            <a:pPr algn="ctr"/>
+            <a:r>
+              <a:rPr sz="1200" b="1" i="0">
+                <a:solidFill>
+                  <a:srgbClr val="FFFFFF"/>
+                </a:solidFill>
+                <a:latin typeface="Calibri"/>
+              </a:rPr>
+              <a:t>Cả nhóm</a:t>
+            </a:r>
+          </a:p>
+        </p:txBody>
+      </p:sp>
+      <p:sp>
+        <p:nvSpPr>
+          <p:cNvPr id="5" name="TextBox 4"/>
+          <p:cNvSpPr txBox="1"/>
+          <p:nvPr/>
+        </p:nvSpPr>
+        <p:spPr>
+          <a:xfrm>
+            <a:off x="600000" y="1450000"/>
+            <a:ext cx="11000000" cy="5000000"/>
+          </a:xfrm>
+          <a:prstGeom prst="rect">
+            <a:avLst/>
+          </a:prstGeom>
+          <a:noFill/>
+        </p:spPr>
+        <p:txBody>
+          <a:bodyPr wrap="square">
+            <a:spAutoFit/>
+          </a:bodyPr>
+          <a:lstStyle/>
+          <a:p>
             <a:pPr>
               <a:spcBef>
                 <a:spcPts val="1000"/>
@@ -7032,6 +6592,916 @@
                 </a:solidFill>
                 <a:latin typeface="Calibri"/>
               </a:rPr>
+              <a:t>Layer 1 (val 142)</a:t>
+            </a:r>
+          </a:p>
+          <a:p>
+            <a:pPr>
+              <a:spcBef>
+                <a:spcPts val="500"/>
+              </a:spcBef>
+            </a:pPr>
+            <a:r>
+              <a:rPr sz="1600" b="0" i="0">
+                <a:solidFill>
+                  <a:srgbClr val="1F2D3D"/>
+                </a:solidFill>
+                <a:latin typeface="Calibri"/>
+              </a:rPr>
+              <a:t>•  Micro F1 = 0.291, Macro F1 = 0.189, Precision = 0.748, Recall = 0.181</a:t>
+            </a:r>
+          </a:p>
+          <a:p>
+            <a:pPr>
+              <a:spcBef>
+                <a:spcPts val="500"/>
+              </a:spcBef>
+            </a:pPr>
+            <a:r>
+              <a:rPr sz="1600" b="0" i="0">
+                <a:solidFill>
+                  <a:srgbClr val="1F2D3D"/>
+                </a:solidFill>
+                <a:latin typeface="Calibri"/>
+              </a:rPr>
+              <a:t>•  Ablation RL: delta macro F1 = 0 (chưa train ablation thành công)</a:t>
+            </a:r>
+          </a:p>
+          <a:p>
+            <a:pPr>
+              <a:spcBef>
+                <a:spcPts val="1000"/>
+              </a:spcBef>
+            </a:pPr>
+            <a:r>
+              <a:rPr sz="1900" b="1" i="0">
+                <a:solidFill>
+                  <a:srgbClr val="E86A17"/>
+                </a:solidFill>
+                <a:latin typeface="Calibri"/>
+              </a:rPr>
+              <a:t>Layer 2</a:t>
+            </a:r>
+          </a:p>
+          <a:p>
+            <a:pPr>
+              <a:spcBef>
+                <a:spcPts val="500"/>
+              </a:spcBef>
+            </a:pPr>
+            <a:r>
+              <a:rPr sz="1600" b="0" i="0">
+                <a:solidFill>
+                  <a:srgbClr val="1F2D3D"/>
+                </a:solidFill>
+                <a:latin typeface="Calibri"/>
+              </a:rPr>
+              <a:t>•  Oracle (709): Hit@5 = 1.0, NDCG@5 = 0.971 — upper bound scoring</a:t>
+            </a:r>
+          </a:p>
+          <a:p>
+            <a:pPr>
+              <a:spcBef>
+                <a:spcPts val="500"/>
+              </a:spcBef>
+            </a:pPr>
+            <a:r>
+              <a:rPr sz="1600" b="0" i="0">
+                <a:solidFill>
+                  <a:srgbClr val="1F2D3D"/>
+                </a:solidFill>
+                <a:latin typeface="Calibri"/>
+              </a:rPr>
+              <a:t>•  Behavioral (104): Hit@5 = 0.039, MRR = 0.017, mean rank ~ 5.87</a:t>
+            </a:r>
+          </a:p>
+          <a:p>
+            <a:pPr>
+              <a:spcBef>
+                <a:spcPts val="1000"/>
+              </a:spcBef>
+            </a:pPr>
+            <a:r>
+              <a:rPr sz="1900" b="1" i="0">
+                <a:solidFill>
+                  <a:srgbClr val="E86A17"/>
+                </a:solidFill>
+                <a:latin typeface="Calibri"/>
+              </a:rPr>
+              <a:t>Layer 3 &amp; Pipeline</a:t>
+            </a:r>
+          </a:p>
+          <a:p>
+            <a:pPr>
+              <a:spcBef>
+                <a:spcPts val="500"/>
+              </a:spcBef>
+            </a:pPr>
+            <a:r>
+              <a:rPr sz="1600" b="0" i="0">
+                <a:solidFill>
+                  <a:srgbClr val="1F2D3D"/>
+                </a:solidFill>
+                <a:latin typeface="Calibri"/>
+              </a:rPr>
+              <a:t>•  L3: success 52.5% (runtime 54.6%, simulated 52.0%), 33 chromosome, avg fitness 2.61</a:t>
+            </a:r>
+          </a:p>
+          <a:p>
+            <a:pPr>
+              <a:spcBef>
+                <a:spcPts val="500"/>
+              </a:spcBef>
+            </a:pPr>
+            <a:r>
+              <a:rPr sz="1600" b="0" i="0">
+                <a:solidFill>
+                  <a:srgbClr val="1F2D3D"/>
+                </a:solidFill>
+                <a:latin typeface="Calibri"/>
+              </a:rPr>
+              <a:t>•  E2E: tag overlap 0.251; Hebbian feedback delta mean +0.647</a:t>
+            </a:r>
+          </a:p>
+          <a:p>
+            <a:pPr>
+              <a:spcBef>
+                <a:spcPts val="800"/>
+              </a:spcBef>
+            </a:pPr>
+            <a:r>
+              <a:rPr sz="1300" b="0" i="1">
+                <a:solidFill>
+                  <a:srgbClr val="127C8A"/>
+                </a:solidFill>
+                <a:latin typeface="Calibri"/>
+              </a:rPr>
+              <a:t>Hạn chế: L2/L3 chủ yếu simulated; L3 không có BLEU/ROUGE</a:t>
+            </a:r>
+          </a:p>
+        </p:txBody>
+      </p:sp>
+    </p:spTree>
+  </p:cSld>
+  <p:clrMapOvr>
+    <a:masterClrMapping/>
+  </p:clrMapOvr>
+</p:sld>
+</file>
+
+<file path=ppt/slides/slide22.xml><?xml version="1.0" encoding="utf-8"?>
+<p:sld xmlns:a="http://schemas.openxmlformats.org/drawingml/2006/main" xmlns:r="http://schemas.openxmlformats.org/officeDocument/2006/relationships" xmlns:p="http://schemas.openxmlformats.org/presentationml/2006/main">
+  <p:cSld>
+    <p:bg>
+      <p:bgPr>
+        <a:solidFill>
+          <a:srgbClr val="F5F1E8"/>
+        </a:solidFill>
+        <a:effectLst/>
+      </p:bgPr>
+    </p:bg>
+    <p:spTree>
+      <p:nvGrpSpPr>
+        <p:cNvPr id="1" name=""/>
+        <p:cNvGrpSpPr/>
+        <p:nvPr/>
+      </p:nvGrpSpPr>
+      <p:grpSpPr>
+        <a:xfrm>
+          <a:off x="0" y="0"/>
+          <a:ext cx="0" cy="0"/>
+          <a:chOff x="0" y="0"/>
+          <a:chExt cx="0" cy="0"/>
+        </a:xfrm>
+      </p:grpSpPr>
+      <p:sp>
+        <p:nvSpPr>
+          <p:cNvPr id="2" name="Rectangle 1"/>
+          <p:cNvSpPr/>
+          <p:nvPr/>
+        </p:nvSpPr>
+        <p:spPr>
+          <a:xfrm>
+            <a:off x="0" y="0"/>
+            <a:ext cx="160000" cy="6858000"/>
+          </a:xfrm>
+          <a:prstGeom prst="rect">
+            <a:avLst/>
+          </a:prstGeom>
+          <a:solidFill>
+            <a:srgbClr val="E86A17"/>
+          </a:solidFill>
+          <a:ln>
+            <a:noFill/>
+          </a:ln>
+        </p:spPr>
+        <p:style>
+          <a:lnRef idx="1">
+            <a:schemeClr val="accent1"/>
+          </a:lnRef>
+          <a:fillRef idx="3">
+            <a:schemeClr val="accent1"/>
+          </a:fillRef>
+          <a:effectRef idx="2">
+            <a:schemeClr val="accent1"/>
+          </a:effectRef>
+          <a:fontRef idx="minor">
+            <a:schemeClr val="lt1"/>
+          </a:fontRef>
+        </p:style>
+        <p:txBody>
+          <a:bodyPr rtlCol="0" anchor="ctr"/>
+          <a:lstStyle/>
+          <a:p>
+            <a:pPr algn="ctr"/>
+            <a:endParaRPr/>
+          </a:p>
+        </p:txBody>
+      </p:sp>
+      <p:sp>
+        <p:nvSpPr>
+          <p:cNvPr id="3" name="TextBox 2"/>
+          <p:cNvSpPr txBox="1"/>
+          <p:nvPr/>
+        </p:nvSpPr>
+        <p:spPr>
+          <a:xfrm>
+            <a:off x="500000" y="350000"/>
+            <a:ext cx="9800000" cy="900000"/>
+          </a:xfrm>
+          <a:prstGeom prst="rect">
+            <a:avLst/>
+          </a:prstGeom>
+          <a:noFill/>
+        </p:spPr>
+        <p:txBody>
+          <a:bodyPr wrap="square">
+            <a:spAutoFit/>
+          </a:bodyPr>
+          <a:lstStyle/>
+          <a:p>
+            <a:r>
+              <a:rPr sz="3000" b="1" i="0">
+                <a:solidFill>
+                  <a:srgbClr val="1F2D3D"/>
+                </a:solidFill>
+                <a:latin typeface="Calibri"/>
+              </a:rPr>
+              <a:t>Triển khai &amp; DevOps</a:t>
+            </a:r>
+          </a:p>
+        </p:txBody>
+      </p:sp>
+      <p:sp>
+        <p:nvSpPr>
+          <p:cNvPr id="4" name="Rectangle 3"/>
+          <p:cNvSpPr/>
+          <p:nvPr/>
+        </p:nvSpPr>
+        <p:spPr>
+          <a:xfrm>
+            <a:off x="9400000" y="380000"/>
+            <a:ext cx="2400000" cy="520000"/>
+          </a:xfrm>
+          <a:prstGeom prst="rect">
+            <a:avLst/>
+          </a:prstGeom>
+          <a:solidFill>
+            <a:srgbClr val="127C8A"/>
+          </a:solidFill>
+          <a:ln>
+            <a:noFill/>
+          </a:ln>
+        </p:spPr>
+        <p:style>
+          <a:lnRef idx="1">
+            <a:schemeClr val="accent1"/>
+          </a:lnRef>
+          <a:fillRef idx="3">
+            <a:schemeClr val="accent1"/>
+          </a:fillRef>
+          <a:effectRef idx="2">
+            <a:schemeClr val="accent1"/>
+          </a:effectRef>
+          <a:fontRef idx="minor">
+            <a:schemeClr val="lt1"/>
+          </a:fontRef>
+        </p:style>
+        <p:txBody>
+          <a:bodyPr wrap="square" rtlCol="0" anchor="ctr"/>
+          <a:lstStyle/>
+          <a:p>
+            <a:pPr algn="ctr"/>
+            <a:r>
+              <a:rPr sz="1200" b="1" i="0">
+                <a:solidFill>
+                  <a:srgbClr val="FFFFFF"/>
+                </a:solidFill>
+                <a:latin typeface="Calibri"/>
+              </a:rPr>
+              <a:t>Đức Anh</a:t>
+            </a:r>
+          </a:p>
+        </p:txBody>
+      </p:sp>
+      <p:sp>
+        <p:nvSpPr>
+          <p:cNvPr id="5" name="TextBox 4"/>
+          <p:cNvSpPr txBox="1"/>
+          <p:nvPr/>
+        </p:nvSpPr>
+        <p:spPr>
+          <a:xfrm>
+            <a:off x="600000" y="1450000"/>
+            <a:ext cx="11000000" cy="5000000"/>
+          </a:xfrm>
+          <a:prstGeom prst="rect">
+            <a:avLst/>
+          </a:prstGeom>
+          <a:noFill/>
+        </p:spPr>
+        <p:txBody>
+          <a:bodyPr wrap="square">
+            <a:spAutoFit/>
+          </a:bodyPr>
+          <a:lstStyle/>
+          <a:p>
+            <a:pPr>
+              <a:spcBef>
+                <a:spcPts val="1000"/>
+              </a:spcBef>
+            </a:pPr>
+            <a:r>
+              <a:rPr sz="1900" b="1" i="0">
+                <a:solidFill>
+                  <a:srgbClr val="E86A17"/>
+                </a:solidFill>
+                <a:latin typeface="Calibri"/>
+              </a:rPr>
+              <a:t>Makefile - một lệnh cho mỗi tác vụ</a:t>
+            </a:r>
+          </a:p>
+          <a:p>
+            <a:pPr>
+              <a:spcBef>
+                <a:spcPts val="500"/>
+              </a:spcBef>
+            </a:pPr>
+            <a:r>
+              <a:rPr sz="1600" b="0" i="0">
+                <a:solidFill>
+                  <a:srgbClr val="1F2D3D"/>
+                </a:solidFill>
+                <a:latin typeface="Calibri"/>
+              </a:rPr>
+              <a:t>•  make setup | app-run | app-demo | eval-run | layer{1,2,3}-*</a:t>
+            </a:r>
+          </a:p>
+          <a:p>
+            <a:pPr>
+              <a:spcBef>
+                <a:spcPts val="1000"/>
+              </a:spcBef>
+            </a:pPr>
+            <a:r>
+              <a:rPr sz="1900" b="1" i="0">
+                <a:solidFill>
+                  <a:srgbClr val="E86A17"/>
+                </a:solidFill>
+                <a:latin typeface="Calibri"/>
+              </a:rPr>
+              <a:t>Docker</a:t>
+            </a:r>
+          </a:p>
+          <a:p>
+            <a:pPr>
+              <a:spcBef>
+                <a:spcPts val="500"/>
+              </a:spcBef>
+            </a:pPr>
+            <a:r>
+              <a:rPr sz="1600" b="0" i="0">
+                <a:solidFill>
+                  <a:srgbClr val="1F2D3D"/>
+                </a:solidFill>
+                <a:latin typeface="Calibri"/>
+              </a:rPr>
+              <a:t>•  docker/layer1|2|3/docker-compose.yml + docker/app/ (full app)</a:t>
+            </a:r>
+          </a:p>
+          <a:p>
+            <a:pPr>
+              <a:spcBef>
+                <a:spcPts val="1000"/>
+              </a:spcBef>
+            </a:pPr>
+            <a:r>
+              <a:rPr sz="1900" b="1" i="0">
+                <a:solidFill>
+                  <a:srgbClr val="E86A17"/>
+                </a:solidFill>
+                <a:latin typeface="Calibri"/>
+              </a:rPr>
+              <a:t>Testing</a:t>
+            </a:r>
+          </a:p>
+          <a:p>
+            <a:pPr>
+              <a:spcBef>
+                <a:spcPts val="500"/>
+              </a:spcBef>
+            </a:pPr>
+            <a:r>
+              <a:rPr sz="1600" b="0" i="0">
+                <a:solidFill>
+                  <a:srgbClr val="1F2D3D"/>
+                </a:solidFill>
+                <a:latin typeface="Calibri"/>
+              </a:rPr>
+              <a:t>•  test_layer2.py, test_layer2_integration.py, test_feedback_logging.py, test_metrics.py</a:t>
+            </a:r>
+          </a:p>
+        </p:txBody>
+      </p:sp>
+    </p:spTree>
+  </p:cSld>
+  <p:clrMapOvr>
+    <a:masterClrMapping/>
+  </p:clrMapOvr>
+</p:sld>
+</file>
+
+<file path=ppt/slides/slide23.xml><?xml version="1.0" encoding="utf-8"?>
+<p:sld xmlns:a="http://schemas.openxmlformats.org/drawingml/2006/main" xmlns:r="http://schemas.openxmlformats.org/officeDocument/2006/relationships" xmlns:p="http://schemas.openxmlformats.org/presentationml/2006/main">
+  <p:cSld>
+    <p:bg>
+      <p:bgPr>
+        <a:solidFill>
+          <a:srgbClr val="F5F1E8"/>
+        </a:solidFill>
+        <a:effectLst/>
+      </p:bgPr>
+    </p:bg>
+    <p:spTree>
+      <p:nvGrpSpPr>
+        <p:cNvPr id="1" name=""/>
+        <p:cNvGrpSpPr/>
+        <p:nvPr/>
+      </p:nvGrpSpPr>
+      <p:grpSpPr>
+        <a:xfrm>
+          <a:off x="0" y="0"/>
+          <a:ext cx="0" cy="0"/>
+          <a:chOff x="0" y="0"/>
+          <a:chExt cx="0" cy="0"/>
+        </a:xfrm>
+      </p:grpSpPr>
+      <p:sp>
+        <p:nvSpPr>
+          <p:cNvPr id="2" name="Rectangle 1"/>
+          <p:cNvSpPr/>
+          <p:nvPr/>
+        </p:nvSpPr>
+        <p:spPr>
+          <a:xfrm>
+            <a:off x="0" y="0"/>
+            <a:ext cx="160000" cy="6858000"/>
+          </a:xfrm>
+          <a:prstGeom prst="rect">
+            <a:avLst/>
+          </a:prstGeom>
+          <a:solidFill>
+            <a:srgbClr val="E86A17"/>
+          </a:solidFill>
+          <a:ln>
+            <a:noFill/>
+          </a:ln>
+        </p:spPr>
+        <p:style>
+          <a:lnRef idx="1">
+            <a:schemeClr val="accent1"/>
+          </a:lnRef>
+          <a:fillRef idx="3">
+            <a:schemeClr val="accent1"/>
+          </a:fillRef>
+          <a:effectRef idx="2">
+            <a:schemeClr val="accent1"/>
+          </a:effectRef>
+          <a:fontRef idx="minor">
+            <a:schemeClr val="lt1"/>
+          </a:fontRef>
+        </p:style>
+        <p:txBody>
+          <a:bodyPr rtlCol="0" anchor="ctr"/>
+          <a:lstStyle/>
+          <a:p>
+            <a:pPr algn="ctr"/>
+            <a:endParaRPr/>
+          </a:p>
+        </p:txBody>
+      </p:sp>
+      <p:sp>
+        <p:nvSpPr>
+          <p:cNvPr id="3" name="TextBox 2"/>
+          <p:cNvSpPr txBox="1"/>
+          <p:nvPr/>
+        </p:nvSpPr>
+        <p:spPr>
+          <a:xfrm>
+            <a:off x="500000" y="350000"/>
+            <a:ext cx="9800000" cy="900000"/>
+          </a:xfrm>
+          <a:prstGeom prst="rect">
+            <a:avLst/>
+          </a:prstGeom>
+          <a:noFill/>
+        </p:spPr>
+        <p:txBody>
+          <a:bodyPr wrap="square">
+            <a:spAutoFit/>
+          </a:bodyPr>
+          <a:lstStyle/>
+          <a:p>
+            <a:r>
+              <a:rPr sz="3000" b="1" i="0">
+                <a:solidFill>
+                  <a:srgbClr val="1F2D3D"/>
+                </a:solidFill>
+                <a:latin typeface="Calibri"/>
+              </a:rPr>
+              <a:t>Demo minh họa</a:t>
+            </a:r>
+          </a:p>
+        </p:txBody>
+      </p:sp>
+      <p:sp>
+        <p:nvSpPr>
+          <p:cNvPr id="4" name="Rectangle 3"/>
+          <p:cNvSpPr/>
+          <p:nvPr/>
+        </p:nvSpPr>
+        <p:spPr>
+          <a:xfrm>
+            <a:off x="9400000" y="380000"/>
+            <a:ext cx="2400000" cy="520000"/>
+          </a:xfrm>
+          <a:prstGeom prst="rect">
+            <a:avLst/>
+          </a:prstGeom>
+          <a:solidFill>
+            <a:srgbClr val="127C8A"/>
+          </a:solidFill>
+          <a:ln>
+            <a:noFill/>
+          </a:ln>
+        </p:spPr>
+        <p:style>
+          <a:lnRef idx="1">
+            <a:schemeClr val="accent1"/>
+          </a:lnRef>
+          <a:fillRef idx="3">
+            <a:schemeClr val="accent1"/>
+          </a:fillRef>
+          <a:effectRef idx="2">
+            <a:schemeClr val="accent1"/>
+          </a:effectRef>
+          <a:fontRef idx="minor">
+            <a:schemeClr val="lt1"/>
+          </a:fontRef>
+        </p:style>
+        <p:txBody>
+          <a:bodyPr wrap="square" rtlCol="0" anchor="ctr"/>
+          <a:lstStyle/>
+          <a:p>
+            <a:pPr algn="ctr"/>
+            <a:r>
+              <a:rPr sz="1200" b="1" i="0">
+                <a:solidFill>
+                  <a:srgbClr val="FFFFFF"/>
+                </a:solidFill>
+                <a:latin typeface="Calibri"/>
+              </a:rPr>
+              <a:t>Minh</a:t>
+            </a:r>
+          </a:p>
+        </p:txBody>
+      </p:sp>
+      <p:sp>
+        <p:nvSpPr>
+          <p:cNvPr id="5" name="TextBox 4"/>
+          <p:cNvSpPr txBox="1"/>
+          <p:nvPr/>
+        </p:nvSpPr>
+        <p:spPr>
+          <a:xfrm>
+            <a:off x="600000" y="1450000"/>
+            <a:ext cx="11000000" cy="5000000"/>
+          </a:xfrm>
+          <a:prstGeom prst="rect">
+            <a:avLst/>
+          </a:prstGeom>
+          <a:noFill/>
+        </p:spPr>
+        <p:txBody>
+          <a:bodyPr wrap="square">
+            <a:spAutoFit/>
+          </a:bodyPr>
+          <a:lstStyle/>
+          <a:p>
+            <a:pPr>
+              <a:spcBef>
+                <a:spcPts val="1000"/>
+              </a:spcBef>
+            </a:pPr>
+            <a:r>
+              <a:rPr sz="1900" b="1" i="0">
+                <a:solidFill>
+                  <a:srgbClr val="E86A17"/>
+                </a:solidFill>
+                <a:latin typeface="Calibri"/>
+              </a:rPr>
+              <a:t>Ví dụ non-interactive (make app-demo)</a:t>
+            </a:r>
+          </a:p>
+          <a:p>
+            <a:pPr lvl="1"/>
+            <a:r>
+              <a:rPr sz="1400" b="0" i="0">
+                <a:solidFill>
+                  <a:srgbClr val="555B66"/>
+                </a:solidFill>
+                <a:latin typeface="Calibri"/>
+              </a:rPr>
+              <a:t>–  Chat 1: 'Tối nay trời lạnh, tôi muốn món nước nóng'</a:t>
+            </a:r>
+          </a:p>
+          <a:p>
+            <a:pPr lvl="1"/>
+            <a:r>
+              <a:rPr sz="1400" b="0" i="0">
+                <a:solidFill>
+                  <a:srgbClr val="555B66"/>
+                </a:solidFill>
+                <a:latin typeface="Calibri"/>
+              </a:rPr>
+              <a:t>–  Bot: câu trả lời genetic + Top 5 món + score</a:t>
+            </a:r>
+          </a:p>
+          <a:p>
+            <a:pPr lvl="1"/>
+            <a:r>
+              <a:rPr sz="1400" b="0" i="0">
+                <a:solidFill>
+                  <a:srgbClr val="555B66"/>
+                </a:solidFill>
+                <a:latin typeface="Calibri"/>
+              </a:rPr>
+              <a:t>–  Chat 2..5: 'Quay xe, giờ tôi muốn món nhanh và tiện lợi'</a:t>
+            </a:r>
+          </a:p>
+          <a:p>
+            <a:pPr lvl="1"/>
+            <a:r>
+              <a:rPr sz="1400" b="0" i="0">
+                <a:solidFill>
+                  <a:srgbClr val="555B66"/>
+                </a:solidFill>
+                <a:latin typeface="Calibri"/>
+              </a:rPr>
+              <a:t>–  Feedback: chosen=dish_001 -&gt; delta score</a:t>
+            </a:r>
+          </a:p>
+          <a:p>
+            <a:pPr>
+              <a:spcBef>
+                <a:spcPts val="1000"/>
+              </a:spcBef>
+            </a:pPr>
+            <a:r>
+              <a:rPr sz="1900" b="1" i="0">
+                <a:solidFill>
+                  <a:srgbClr val="E86A17"/>
+                </a:solidFill>
+                <a:latin typeface="Calibri"/>
+              </a:rPr>
+              <a:t>Điểm cần nhấn</a:t>
+            </a:r>
+          </a:p>
+          <a:p>
+            <a:pPr>
+              <a:spcBef>
+                <a:spcPts val="500"/>
+              </a:spcBef>
+            </a:pPr>
+            <a:r>
+              <a:rPr sz="1600" b="0" i="0">
+                <a:solidFill>
+                  <a:srgbClr val="1F2D3D"/>
+                </a:solidFill>
+                <a:latin typeface="Calibri"/>
+              </a:rPr>
+              <a:t>•  DST xử lý 'quay xe' | score món đổi sau feedback | câu trả lời theo mood</a:t>
+            </a:r>
+          </a:p>
+        </p:txBody>
+      </p:sp>
+    </p:spTree>
+  </p:cSld>
+  <p:clrMapOvr>
+    <a:masterClrMapping/>
+  </p:clrMapOvr>
+</p:sld>
+</file>
+
+<file path=ppt/slides/slide24.xml><?xml version="1.0" encoding="utf-8"?>
+<p:sld xmlns:a="http://schemas.openxmlformats.org/drawingml/2006/main" xmlns:r="http://schemas.openxmlformats.org/officeDocument/2006/relationships" xmlns:p="http://schemas.openxmlformats.org/presentationml/2006/main">
+  <p:cSld>
+    <p:bg>
+      <p:bgPr>
+        <a:solidFill>
+          <a:srgbClr val="F5F1E8"/>
+        </a:solidFill>
+        <a:effectLst/>
+      </p:bgPr>
+    </p:bg>
+    <p:spTree>
+      <p:nvGrpSpPr>
+        <p:cNvPr id="1" name=""/>
+        <p:cNvGrpSpPr/>
+        <p:nvPr/>
+      </p:nvGrpSpPr>
+      <p:grpSpPr>
+        <a:xfrm>
+          <a:off x="0" y="0"/>
+          <a:ext cx="0" cy="0"/>
+          <a:chOff x="0" y="0"/>
+          <a:chExt cx="0" cy="0"/>
+        </a:xfrm>
+      </p:grpSpPr>
+      <p:sp>
+        <p:nvSpPr>
+          <p:cNvPr id="2" name="Rectangle 1"/>
+          <p:cNvSpPr/>
+          <p:nvPr/>
+        </p:nvSpPr>
+        <p:spPr>
+          <a:xfrm>
+            <a:off x="0" y="0"/>
+            <a:ext cx="160000" cy="6858000"/>
+          </a:xfrm>
+          <a:prstGeom prst="rect">
+            <a:avLst/>
+          </a:prstGeom>
+          <a:solidFill>
+            <a:srgbClr val="E86A17"/>
+          </a:solidFill>
+          <a:ln>
+            <a:noFill/>
+          </a:ln>
+        </p:spPr>
+        <p:style>
+          <a:lnRef idx="1">
+            <a:schemeClr val="accent1"/>
+          </a:lnRef>
+          <a:fillRef idx="3">
+            <a:schemeClr val="accent1"/>
+          </a:fillRef>
+          <a:effectRef idx="2">
+            <a:schemeClr val="accent1"/>
+          </a:effectRef>
+          <a:fontRef idx="minor">
+            <a:schemeClr val="lt1"/>
+          </a:fontRef>
+        </p:style>
+        <p:txBody>
+          <a:bodyPr rtlCol="0" anchor="ctr"/>
+          <a:lstStyle/>
+          <a:p>
+            <a:pPr algn="ctr"/>
+            <a:endParaRPr/>
+          </a:p>
+        </p:txBody>
+      </p:sp>
+      <p:sp>
+        <p:nvSpPr>
+          <p:cNvPr id="3" name="TextBox 2"/>
+          <p:cNvSpPr txBox="1"/>
+          <p:nvPr/>
+        </p:nvSpPr>
+        <p:spPr>
+          <a:xfrm>
+            <a:off x="500000" y="350000"/>
+            <a:ext cx="9800000" cy="900000"/>
+          </a:xfrm>
+          <a:prstGeom prst="rect">
+            <a:avLst/>
+          </a:prstGeom>
+          <a:noFill/>
+        </p:spPr>
+        <p:txBody>
+          <a:bodyPr wrap="square">
+            <a:spAutoFit/>
+          </a:bodyPr>
+          <a:lstStyle/>
+          <a:p>
+            <a:r>
+              <a:rPr sz="3000" b="1" i="0">
+                <a:solidFill>
+                  <a:srgbClr val="1F2D3D"/>
+                </a:solidFill>
+                <a:latin typeface="Calibri"/>
+              </a:rPr>
+              <a:t>Hạn chế &amp; Kết luận</a:t>
+            </a:r>
+          </a:p>
+        </p:txBody>
+      </p:sp>
+      <p:sp>
+        <p:nvSpPr>
+          <p:cNvPr id="4" name="Rectangle 3"/>
+          <p:cNvSpPr/>
+          <p:nvPr/>
+        </p:nvSpPr>
+        <p:spPr>
+          <a:xfrm>
+            <a:off x="9400000" y="380000"/>
+            <a:ext cx="2400000" cy="520000"/>
+          </a:xfrm>
+          <a:prstGeom prst="rect">
+            <a:avLst/>
+          </a:prstGeom>
+          <a:solidFill>
+            <a:srgbClr val="127C8A"/>
+          </a:solidFill>
+          <a:ln>
+            <a:noFill/>
+          </a:ln>
+        </p:spPr>
+        <p:style>
+          <a:lnRef idx="1">
+            <a:schemeClr val="accent1"/>
+          </a:lnRef>
+          <a:fillRef idx="3">
+            <a:schemeClr val="accent1"/>
+          </a:fillRef>
+          <a:effectRef idx="2">
+            <a:schemeClr val="accent1"/>
+          </a:effectRef>
+          <a:fontRef idx="minor">
+            <a:schemeClr val="lt1"/>
+          </a:fontRef>
+        </p:style>
+        <p:txBody>
+          <a:bodyPr wrap="square" rtlCol="0" anchor="ctr"/>
+          <a:lstStyle/>
+          <a:p>
+            <a:pPr algn="ctr"/>
+            <a:r>
+              <a:rPr sz="1200" b="1" i="0">
+                <a:solidFill>
+                  <a:srgbClr val="FFFFFF"/>
+                </a:solidFill>
+                <a:latin typeface="Calibri"/>
+              </a:rPr>
+              <a:t>Cả nhóm</a:t>
+            </a:r>
+          </a:p>
+        </p:txBody>
+      </p:sp>
+      <p:sp>
+        <p:nvSpPr>
+          <p:cNvPr id="5" name="TextBox 4"/>
+          <p:cNvSpPr txBox="1"/>
+          <p:nvPr/>
+        </p:nvSpPr>
+        <p:spPr>
+          <a:xfrm>
+            <a:off x="600000" y="1450000"/>
+            <a:ext cx="11000000" cy="5000000"/>
+          </a:xfrm>
+          <a:prstGeom prst="rect">
+            <a:avLst/>
+          </a:prstGeom>
+          <a:noFill/>
+        </p:spPr>
+        <p:txBody>
+          <a:bodyPr wrap="square">
+            <a:spAutoFit/>
+          </a:bodyPr>
+          <a:lstStyle/>
+          <a:p>
+            <a:pPr>
+              <a:spcBef>
+                <a:spcPts val="1000"/>
+              </a:spcBef>
+            </a:pPr>
+            <a:r>
+              <a:rPr sz="1900" b="1" i="0">
+                <a:solidFill>
+                  <a:srgbClr val="E86A17"/>
+                </a:solidFill>
+                <a:latin typeface="Calibri"/>
+              </a:rPr>
               <a:t>Ưu điểm</a:t>
             </a:r>
           </a:p>
@@ -7048,7 +7518,23 @@
                 </a:solidFill>
                 <a:latin typeface="Calibri"/>
               </a:rPr>
-              <a:t>•  Modular, offline, kết hợp DL multi-label + DST + Hebbian + GA + RL offline</a:t>
+              <a:t>•  Modular, offline, DL multi-label + DST + Hebbian + GA + RL offline</a:t>
+            </a:r>
+          </a:p>
+          <a:p>
+            <a:pPr>
+              <a:spcBef>
+                <a:spcPts val="500"/>
+              </a:spcBef>
+            </a:pPr>
+            <a:r>
+              <a:rPr sz="1600" b="0" i="0">
+                <a:solidFill>
+                  <a:srgbClr val="1F2D3D"/>
+                </a:solidFill>
+                <a:latin typeface="Calibri"/>
+              </a:rPr>
+              <a:t>•  Đã có pipeline đánh giá định lượng (make eval-run)</a:t>
             </a:r>
           </a:p>
           <a:p>
@@ -7064,6 +7550,38 @@
                 </a:solidFill>
                 <a:latin typeface="Calibri"/>
               </a:rPr>
+              <a:t>Kết quả nổi bật</a:t>
+            </a:r>
+          </a:p>
+          <a:p>
+            <a:pPr>
+              <a:spcBef>
+                <a:spcPts val="500"/>
+              </a:spcBef>
+            </a:pPr>
+            <a:r>
+              <a:rPr sz="1600" b="0" i="0">
+                <a:solidFill>
+                  <a:srgbClr val="1F2D3D"/>
+                </a:solidFill>
+                <a:latin typeface="Calibri"/>
+              </a:rPr>
+              <a:t>•  L2 Oracle Hit@5 = 1.0 | L3 success rate ~ 52.5% | Hebbian delta +0.647</a:t>
+            </a:r>
+          </a:p>
+          <a:p>
+            <a:pPr>
+              <a:spcBef>
+                <a:spcPts val="1000"/>
+              </a:spcBef>
+            </a:pPr>
+            <a:r>
+              <a:rPr sz="1900" b="1" i="0">
+                <a:solidFill>
+                  <a:srgbClr val="E86A17"/>
+                </a:solidFill>
+                <a:latin typeface="Calibri"/>
+              </a:rPr>
               <a:t>Hạn chế</a:t>
             </a:r>
           </a:p>
@@ -7080,7 +7598,23 @@
                 </a:solidFill>
                 <a:latin typeface="Calibri"/>
               </a:rPr>
-              <a:t>•  Dataset nhỏ (~160 mẫu/epoch, 100 món); L3 template cố định; chưa có UI</a:t>
+              <a:t>•  Dataset nhỏ; L2 behavioral Hit@5 thấp (0.039); L1 recall thấp (0.18)</a:t>
+            </a:r>
+          </a:p>
+          <a:p>
+            <a:pPr>
+              <a:spcBef>
+                <a:spcPts val="500"/>
+              </a:spcBef>
+            </a:pPr>
+            <a:r>
+              <a:rPr sz="1600" b="0" i="0">
+                <a:solidFill>
+                  <a:srgbClr val="1F2D3D"/>
+                </a:solidFill>
+                <a:latin typeface="Calibri"/>
+              </a:rPr>
+              <a:t>•  L2/L3 eval chủ yếu simulated; chưa có UI</a:t>
             </a:r>
           </a:p>
           <a:p>
@@ -7112,7 +7646,7 @@
                 </a:solidFill>
                 <a:latin typeface="Calibri"/>
               </a:rPr>
-              <a:t>•  Mở rộng corpus, UI chat, đánh giá định lượng, RL train định kỳ</a:t>
+              <a:t>•  Thu thập phiên chat thật, mở rộng corpus, UI, ablation RL L1</a:t>
             </a:r>
           </a:p>
           <a:p>
@@ -7682,8 +8216,8 @@
         </p:blipFill>
         <p:spPr>
           <a:xfrm>
-            <a:off x="2506560" y="2565918"/>
-            <a:ext cx="7186879" cy="4134082"/>
+            <a:off x="2417347" y="2463282"/>
+            <a:ext cx="7365306" cy="4236718"/>
           </a:xfrm>
           <a:prstGeom prst="rect">
             <a:avLst/>
@@ -8058,8 +8592,8 @@
         </p:blipFill>
         <p:spPr>
           <a:xfrm>
-            <a:off x="2553364" y="2864498"/>
-            <a:ext cx="7093271" cy="3835502"/>
+            <a:off x="2363550" y="2659224"/>
+            <a:ext cx="7472899" cy="4040776"/>
           </a:xfrm>
           <a:prstGeom prst="rect">
             <a:avLst/>

</xml_diff>